<commit_message>
docs: diapositiva de pytest (alcance + conexion con la clase) en seccion de Brayan
Co-Authored-By: Claude Opus 4.8 <noreply@anthropic.com>
</commit_message>
<xml_diff>
--- a/presentacion_agendapp.pptx
+++ b/presentacion_agendapp.pptx
@@ -15,9 +15,10 @@
     <p:sldId id="263" r:id="rId9"/>
     <p:sldId id="264" r:id="rId10"/>
     <p:sldId id="265" r:id="rId11"/>
+    <p:sldId id="266" r:id="rId12"/>
   </p:sldIdLst>
   <p:notesMasterIdLst>
-    <p:notesMasterId r:id="rId12"/>
+    <p:notesMasterId r:id="rId13"/>
   </p:notesMasterIdLst>
   <p:sldSz cx="12192000" cy="6858000"/>
   <p:notesSz cx="6858000" cy="12192000"/>
@@ -623,6 +624,94 @@
             <a:fld id="{F7021451-1387-4CA6-816F-3879F97B5CBC}" type="slidenum">
               <a:rPr lang="en-US"/>
               <a:t>10</a:t>
+            </a:fld>
+            <a:endParaRPr lang="en-US"/>
+          </a:p>
+        </p:txBody>
+      </p:sp>
+    </p:spTree>
+    <p:extLst>
+      <p:ext uri="{BB962C8B-B14F-4D97-AF65-F5344CB8AC3E}">
+        <p14:creationId xmlns:p14="http://schemas.microsoft.com/office/powerpoint/2010/main" val="1024086991"/>
+      </p:ext>
+    </p:extLst>
+  </p:cSld>
+  <p:clrMapOvr>
+    <a:masterClrMapping/>
+  </p:clrMapOvr>
+</p:notes>
+</file>
+
+<file path=ppt/notesSlides/notesSlide11.xml><?xml version="1.0" encoding="utf-8"?>
+<p:notes xmlns:a="http://schemas.openxmlformats.org/drawingml/2006/main" xmlns:r="http://schemas.openxmlformats.org/officeDocument/2006/relationships" xmlns:p="http://schemas.openxmlformats.org/presentationml/2006/main">
+  <p:cSld>
+    <p:spTree>
+      <p:nvGrpSpPr>
+        <p:cNvPr id="1" name=""/>
+        <p:cNvGrpSpPr/>
+        <p:nvPr/>
+      </p:nvGrpSpPr>
+      <p:grpSpPr>
+        <a:xfrm>
+          <a:off x="0" y="0"/>
+          <a:ext cx="0" cy="0"/>
+          <a:chOff x="0" y="0"/>
+          <a:chExt cx="0" cy="0"/>
+        </a:xfrm>
+      </p:grpSpPr>
+      <p:sp>
+        <p:nvSpPr>
+          <p:cNvPr id="2" name="Slide Image Placeholder 1"/>
+          <p:cNvSpPr>
+            <a:spLocks noGrp="1" noRot="1" noChangeAspect="1"/>
+          </p:cNvSpPr>
+          <p:nvPr>
+            <p:ph type="sldImg"/>
+          </p:nvPr>
+        </p:nvSpPr>
+        <p:spPr/>
+      </p:sp>
+      <p:sp>
+        <p:nvSpPr>
+          <p:cNvPr id="3" name="Notes Placeholder 2"/>
+          <p:cNvSpPr>
+            <a:spLocks noGrp="1"/>
+          </p:cNvSpPr>
+          <p:nvPr>
+            <p:ph type="body" idx="1"/>
+          </p:nvPr>
+        </p:nvSpPr>
+        <p:spPr/>
+        <p:txBody>
+          <a:bodyPr/>
+          <a:lstStyle/>
+          <a:p>
+            <a:r>
+              <a:rPr lang="en-US" dirty="0"/>
+              <a:t/>
+            </a:r>
+            <a:endParaRPr lang="en-US" dirty="0"/>
+          </a:p>
+        </p:txBody>
+      </p:sp>
+      <p:sp>
+        <p:nvSpPr>
+          <p:cNvPr id="4" name="Slide Number Placeholder 3"/>
+          <p:cNvSpPr>
+            <a:spLocks noGrp="1"/>
+          </p:cNvSpPr>
+          <p:nvPr>
+            <p:ph type="sldNum" sz="quarter" idx="10"/>
+          </p:nvPr>
+        </p:nvSpPr>
+        <p:spPr/>
+        <p:txBody>
+          <a:bodyPr/>
+          <a:lstStyle/>
+          <a:p>
+            <a:fld id="{F7021451-1387-4CA6-816F-3879F97B5CBC}" type="slidenum">
+              <a:rPr lang="en-US"/>
+              <a:t>11</a:t>
             </a:fld>
             <a:endParaRPr lang="en-US"/>
           </a:p>
@@ -1892,6 +1981,631 @@
 <file path=ppt/slides/slide10.xml><?xml version="1.0" encoding="utf-8"?>
 <p:sld xmlns:a="http://schemas.openxmlformats.org/drawingml/2006/main" xmlns:r="http://schemas.openxmlformats.org/officeDocument/2006/relationships" xmlns:p="http://schemas.openxmlformats.org/presentationml/2006/main">
   <p:cSld name="Slide 10">
+    <p:spTree>
+      <p:nvGrpSpPr>
+        <p:cNvPr id="1" name=""/>
+        <p:cNvGrpSpPr/>
+        <p:nvPr/>
+      </p:nvGrpSpPr>
+      <p:grpSpPr>
+        <a:xfrm>
+          <a:off x="0" y="0"/>
+          <a:ext cx="0" cy="0"/>
+          <a:chOff x="0" y="0"/>
+          <a:chExt cx="0" cy="0"/>
+        </a:xfrm>
+      </p:grpSpPr>
+      <p:sp>
+        <p:nvSpPr>
+          <p:cNvPr id="2" name="Text 0"/>
+          <p:cNvSpPr/>
+          <p:nvPr/>
+        </p:nvSpPr>
+        <p:spPr>
+          <a:xfrm>
+            <a:off x="548640" y="384048"/>
+            <a:ext cx="9052560" cy="868680"/>
+          </a:xfrm>
+          <a:prstGeom prst="rect">
+            <a:avLst/>
+          </a:prstGeom>
+          <a:noFill/>
+          <a:ln/>
+        </p:spPr>
+        <p:txBody>
+          <a:bodyPr wrap="square" rtlCol="0" anchor="ctr"/>
+          <a:lstStyle/>
+          <a:p>
+            <a:pPr indent="0" marL="0">
+              <a:buNone/>
+            </a:pPr>
+            <a:r>
+              <a:rPr lang="en-US" sz="2700" b="1" dirty="0">
+                <a:solidFill>
+                  <a:srgbClr val="16243F"/>
+                </a:solidFill>
+                <a:latin typeface="Georgia" pitchFamily="34" charset="0"/>
+                <a:ea typeface="Georgia" pitchFamily="34" charset="-122"/>
+                <a:cs typeface="Georgia" pitchFamily="34" charset="-120"/>
+              </a:rPr>
+              <a:t>Modo demo para validación del docente</a:t>
+            </a:r>
+            <a:endParaRPr lang="en-US" sz="2700" dirty="0"/>
+          </a:p>
+        </p:txBody>
+      </p:sp>
+      <p:sp>
+        <p:nvSpPr>
+          <p:cNvPr id="3" name="Shape 1"/>
+          <p:cNvSpPr/>
+          <p:nvPr/>
+        </p:nvSpPr>
+        <p:spPr>
+          <a:xfrm>
+            <a:off x="9829800" y="411480"/>
+            <a:ext cx="1828800" cy="457200"/>
+          </a:xfrm>
+          <a:prstGeom prst="roundRect">
+            <a:avLst>
+              <a:gd name="adj" fmla="val 50000"/>
+            </a:avLst>
+          </a:prstGeom>
+          <a:solidFill>
+            <a:srgbClr val="19C3A3"/>
+          </a:solidFill>
+          <a:ln/>
+        </p:spPr>
+      </p:sp>
+      <p:sp>
+        <p:nvSpPr>
+          <p:cNvPr id="4" name="Text 2"/>
+          <p:cNvSpPr/>
+          <p:nvPr/>
+        </p:nvSpPr>
+        <p:spPr>
+          <a:xfrm>
+            <a:off x="9829800" y="411480"/>
+            <a:ext cx="1828800" cy="457200"/>
+          </a:xfrm>
+          <a:prstGeom prst="rect">
+            <a:avLst/>
+          </a:prstGeom>
+          <a:noFill/>
+          <a:ln/>
+        </p:spPr>
+        <p:txBody>
+          <a:bodyPr wrap="square" rtlCol="0" anchor="ctr"/>
+          <a:lstStyle/>
+          <a:p>
+            <a:pPr algn="ctr" indent="0" marL="0">
+              <a:buNone/>
+            </a:pPr>
+            <a:r>
+              <a:rPr lang="en-US" sz="1300" b="1" dirty="0">
+                <a:solidFill>
+                  <a:srgbClr val="06281F"/>
+                </a:solidFill>
+              </a:rPr>
+              <a:t>Brayan / Todos</a:t>
+            </a:r>
+            <a:endParaRPr lang="en-US" sz="1300" dirty="0"/>
+          </a:p>
+        </p:txBody>
+      </p:sp>
+      <p:sp>
+        <p:nvSpPr>
+          <p:cNvPr id="5" name="Text 3"/>
+          <p:cNvSpPr/>
+          <p:nvPr/>
+        </p:nvSpPr>
+        <p:spPr>
+          <a:xfrm>
+            <a:off x="548640" y="1463040"/>
+            <a:ext cx="5669280" cy="457200"/>
+          </a:xfrm>
+          <a:prstGeom prst="rect">
+            <a:avLst/>
+          </a:prstGeom>
+          <a:noFill/>
+          <a:ln/>
+        </p:spPr>
+        <p:txBody>
+          <a:bodyPr wrap="square" rtlCol="0" anchor="ctr"/>
+          <a:lstStyle/>
+          <a:p>
+            <a:pPr indent="0" marL="0">
+              <a:buNone/>
+            </a:pPr>
+            <a:r>
+              <a:rPr lang="en-US" sz="1700" dirty="0">
+                <a:solidFill>
+                  <a:srgbClr val="1F2A3A"/>
+                </a:solidFill>
+              </a:rPr>
+              <a:t>El docente puede validar las pruebas sin instalar nada.</a:t>
+            </a:r>
+            <a:endParaRPr lang="en-US" sz="1700" dirty="0"/>
+          </a:p>
+        </p:txBody>
+      </p:sp>
+      <p:sp>
+        <p:nvSpPr>
+          <p:cNvPr id="6" name="Shape 4"/>
+          <p:cNvSpPr/>
+          <p:nvPr/>
+        </p:nvSpPr>
+        <p:spPr>
+          <a:xfrm>
+            <a:off x="548640" y="2103120"/>
+            <a:ext cx="5669280" cy="640080"/>
+          </a:xfrm>
+          <a:prstGeom prst="roundRect">
+            <a:avLst>
+              <a:gd name="adj" fmla="val 11429"/>
+            </a:avLst>
+          </a:prstGeom>
+          <a:solidFill>
+            <a:srgbClr val="FFFFFF"/>
+          </a:solidFill>
+          <a:ln w="12700">
+            <a:solidFill>
+              <a:srgbClr val="D5DEEC"/>
+            </a:solidFill>
+            <a:prstDash val="solid"/>
+          </a:ln>
+        </p:spPr>
+      </p:sp>
+      <p:sp>
+        <p:nvSpPr>
+          <p:cNvPr id="7" name="Text 5"/>
+          <p:cNvSpPr/>
+          <p:nvPr/>
+        </p:nvSpPr>
+        <p:spPr>
+          <a:xfrm>
+            <a:off x="731520" y="2103120"/>
+            <a:ext cx="1828800" cy="640080"/>
+          </a:xfrm>
+          <a:prstGeom prst="rect">
+            <a:avLst/>
+          </a:prstGeom>
+          <a:noFill/>
+          <a:ln/>
+        </p:spPr>
+        <p:txBody>
+          <a:bodyPr wrap="square" rtlCol="0" anchor="ctr"/>
+          <a:lstStyle/>
+          <a:p>
+            <a:pPr indent="0" marL="0">
+              <a:buNone/>
+            </a:pPr>
+            <a:r>
+              <a:rPr lang="en-US" sz="1400" b="1" dirty="0">
+                <a:solidFill>
+                  <a:srgbClr val="16243F"/>
+                </a:solidFill>
+              </a:rPr>
+              <a:t>Docente (admin)</a:t>
+            </a:r>
+            <a:endParaRPr lang="en-US" sz="1400" dirty="0"/>
+          </a:p>
+        </p:txBody>
+      </p:sp>
+      <p:sp>
+        <p:nvSpPr>
+          <p:cNvPr id="8" name="Text 6"/>
+          <p:cNvSpPr/>
+          <p:nvPr/>
+        </p:nvSpPr>
+        <p:spPr>
+          <a:xfrm>
+            <a:off x="2468880" y="2103120"/>
+            <a:ext cx="3657600" cy="640080"/>
+          </a:xfrm>
+          <a:prstGeom prst="rect">
+            <a:avLst/>
+          </a:prstGeom>
+          <a:noFill/>
+          <a:ln/>
+        </p:spPr>
+        <p:txBody>
+          <a:bodyPr wrap="square" rtlCol="0" anchor="ctr"/>
+          <a:lstStyle/>
+          <a:p>
+            <a:pPr indent="0" marL="0">
+              <a:buNone/>
+            </a:pPr>
+            <a:r>
+              <a:rPr lang="en-US" sz="1300" dirty="0">
+                <a:solidFill>
+                  <a:srgbClr val="1C7293"/>
+                </a:solidFill>
+                <a:latin typeface="Consolas" pitchFamily="34" charset="0"/>
+                <a:ea typeface="Consolas" pitchFamily="34" charset="-122"/>
+                <a:cs typeface="Consolas" pitchFamily="34" charset="-120"/>
+              </a:rPr>
+              <a:t>docente@agendapp.co · Demo2026!</a:t>
+            </a:r>
+            <a:endParaRPr lang="en-US" sz="1300" dirty="0"/>
+          </a:p>
+        </p:txBody>
+      </p:sp>
+      <p:sp>
+        <p:nvSpPr>
+          <p:cNvPr id="9" name="Shape 7"/>
+          <p:cNvSpPr/>
+          <p:nvPr/>
+        </p:nvSpPr>
+        <p:spPr>
+          <a:xfrm>
+            <a:off x="548640" y="2880360"/>
+            <a:ext cx="5669280" cy="640080"/>
+          </a:xfrm>
+          <a:prstGeom prst="roundRect">
+            <a:avLst>
+              <a:gd name="adj" fmla="val 11429"/>
+            </a:avLst>
+          </a:prstGeom>
+          <a:solidFill>
+            <a:srgbClr val="FFFFFF"/>
+          </a:solidFill>
+          <a:ln w="12700">
+            <a:solidFill>
+              <a:srgbClr val="D5DEEC"/>
+            </a:solidFill>
+            <a:prstDash val="solid"/>
+          </a:ln>
+        </p:spPr>
+      </p:sp>
+      <p:sp>
+        <p:nvSpPr>
+          <p:cNvPr id="10" name="Text 8"/>
+          <p:cNvSpPr/>
+          <p:nvPr/>
+        </p:nvSpPr>
+        <p:spPr>
+          <a:xfrm>
+            <a:off x="731520" y="2880360"/>
+            <a:ext cx="1828800" cy="640080"/>
+          </a:xfrm>
+          <a:prstGeom prst="rect">
+            <a:avLst/>
+          </a:prstGeom>
+          <a:noFill/>
+          <a:ln/>
+        </p:spPr>
+        <p:txBody>
+          <a:bodyPr wrap="square" rtlCol="0" anchor="ctr"/>
+          <a:lstStyle/>
+          <a:p>
+            <a:pPr indent="0" marL="0">
+              <a:buNone/>
+            </a:pPr>
+            <a:r>
+              <a:rPr lang="en-US" sz="1400" b="1" dirty="0">
+                <a:solidFill>
+                  <a:srgbClr val="16243F"/>
+                </a:solidFill>
+              </a:rPr>
+              <a:t>Médico</a:t>
+            </a:r>
+            <a:endParaRPr lang="en-US" sz="1400" dirty="0"/>
+          </a:p>
+        </p:txBody>
+      </p:sp>
+      <p:sp>
+        <p:nvSpPr>
+          <p:cNvPr id="11" name="Text 9"/>
+          <p:cNvSpPr/>
+          <p:nvPr/>
+        </p:nvSpPr>
+        <p:spPr>
+          <a:xfrm>
+            <a:off x="2468880" y="2880360"/>
+            <a:ext cx="3657600" cy="640080"/>
+          </a:xfrm>
+          <a:prstGeom prst="rect">
+            <a:avLst/>
+          </a:prstGeom>
+          <a:noFill/>
+          <a:ln/>
+        </p:spPr>
+        <p:txBody>
+          <a:bodyPr wrap="square" rtlCol="0" anchor="ctr"/>
+          <a:lstStyle/>
+          <a:p>
+            <a:pPr indent="0" marL="0">
+              <a:buNone/>
+            </a:pPr>
+            <a:r>
+              <a:rPr lang="en-US" sz="1300" dirty="0">
+                <a:solidFill>
+                  <a:srgbClr val="1C7293"/>
+                </a:solidFill>
+                <a:latin typeface="Consolas" pitchFamily="34" charset="0"/>
+                <a:ea typeface="Consolas" pitchFamily="34" charset="-122"/>
+                <a:cs typeface="Consolas" pitchFamily="34" charset="-120"/>
+              </a:rPr>
+              <a:t>dr.garcia@agendapp.co · Doctor2024!</a:t>
+            </a:r>
+            <a:endParaRPr lang="en-US" sz="1300" dirty="0"/>
+          </a:p>
+        </p:txBody>
+      </p:sp>
+      <p:sp>
+        <p:nvSpPr>
+          <p:cNvPr id="12" name="Shape 10"/>
+          <p:cNvSpPr/>
+          <p:nvPr/>
+        </p:nvSpPr>
+        <p:spPr>
+          <a:xfrm>
+            <a:off x="548640" y="3657600"/>
+            <a:ext cx="5669280" cy="640080"/>
+          </a:xfrm>
+          <a:prstGeom prst="roundRect">
+            <a:avLst>
+              <a:gd name="adj" fmla="val 11429"/>
+            </a:avLst>
+          </a:prstGeom>
+          <a:solidFill>
+            <a:srgbClr val="FFFFFF"/>
+          </a:solidFill>
+          <a:ln w="12700">
+            <a:solidFill>
+              <a:srgbClr val="D5DEEC"/>
+            </a:solidFill>
+            <a:prstDash val="solid"/>
+          </a:ln>
+        </p:spPr>
+      </p:sp>
+      <p:sp>
+        <p:nvSpPr>
+          <p:cNvPr id="13" name="Text 11"/>
+          <p:cNvSpPr/>
+          <p:nvPr/>
+        </p:nvSpPr>
+        <p:spPr>
+          <a:xfrm>
+            <a:off x="731520" y="3657600"/>
+            <a:ext cx="1828800" cy="640080"/>
+          </a:xfrm>
+          <a:prstGeom prst="rect">
+            <a:avLst/>
+          </a:prstGeom>
+          <a:noFill/>
+          <a:ln/>
+        </p:spPr>
+        <p:txBody>
+          <a:bodyPr wrap="square" rtlCol="0" anchor="ctr"/>
+          <a:lstStyle/>
+          <a:p>
+            <a:pPr indent="0" marL="0">
+              <a:buNone/>
+            </a:pPr>
+            <a:r>
+              <a:rPr lang="en-US" sz="1400" b="1" dirty="0">
+                <a:solidFill>
+                  <a:srgbClr val="16243F"/>
+                </a:solidFill>
+              </a:rPr>
+              <a:t>Paciente</a:t>
+            </a:r>
+            <a:endParaRPr lang="en-US" sz="1400" dirty="0"/>
+          </a:p>
+        </p:txBody>
+      </p:sp>
+      <p:sp>
+        <p:nvSpPr>
+          <p:cNvPr id="14" name="Text 12"/>
+          <p:cNvSpPr/>
+          <p:nvPr/>
+        </p:nvSpPr>
+        <p:spPr>
+          <a:xfrm>
+            <a:off x="2468880" y="3657600"/>
+            <a:ext cx="3657600" cy="640080"/>
+          </a:xfrm>
+          <a:prstGeom prst="rect">
+            <a:avLst/>
+          </a:prstGeom>
+          <a:noFill/>
+          <a:ln/>
+        </p:spPr>
+        <p:txBody>
+          <a:bodyPr wrap="square" rtlCol="0" anchor="ctr"/>
+          <a:lstStyle/>
+          <a:p>
+            <a:pPr indent="0" marL="0">
+              <a:buNone/>
+            </a:pPr>
+            <a:r>
+              <a:rPr lang="en-US" sz="1300" dirty="0">
+                <a:solidFill>
+                  <a:srgbClr val="1C7293"/>
+                </a:solidFill>
+                <a:latin typeface="Consolas" pitchFamily="34" charset="0"/>
+                <a:ea typeface="Consolas" pitchFamily="34" charset="-122"/>
+                <a:cs typeface="Consolas" pitchFamily="34" charset="-120"/>
+              </a:rPr>
+              <a:t>maria@test.co · Paciente2024!</a:t>
+            </a:r>
+            <a:endParaRPr lang="en-US" sz="1300" dirty="0"/>
+          </a:p>
+        </p:txBody>
+      </p:sp>
+      <p:sp>
+        <p:nvSpPr>
+          <p:cNvPr id="15" name="Shape 13"/>
+          <p:cNvSpPr/>
+          <p:nvPr/>
+        </p:nvSpPr>
+        <p:spPr>
+          <a:xfrm>
+            <a:off x="548640" y="4617720"/>
+            <a:ext cx="5669280" cy="548640"/>
+          </a:xfrm>
+          <a:prstGeom prst="roundRect">
+            <a:avLst>
+              <a:gd name="adj" fmla="val 13333"/>
+            </a:avLst>
+          </a:prstGeom>
+          <a:solidFill>
+            <a:srgbClr val="F1F5FC"/>
+          </a:solidFill>
+          <a:ln/>
+        </p:spPr>
+      </p:sp>
+      <p:sp>
+        <p:nvSpPr>
+          <p:cNvPr id="16" name="Text 14"/>
+          <p:cNvSpPr/>
+          <p:nvPr/>
+        </p:nvSpPr>
+        <p:spPr>
+          <a:xfrm>
+            <a:off x="548640" y="4617720"/>
+            <a:ext cx="5669280" cy="548640"/>
+          </a:xfrm>
+          <a:prstGeom prst="rect">
+            <a:avLst/>
+          </a:prstGeom>
+          <a:noFill/>
+          <a:ln/>
+        </p:spPr>
+        <p:txBody>
+          <a:bodyPr wrap="square" rtlCol="0" anchor="ctr"/>
+          <a:lstStyle/>
+          <a:p>
+            <a:pPr algn="ctr" indent="0" marL="0">
+              <a:buNone/>
+            </a:pPr>
+            <a:r>
+              <a:rPr lang="en-US" sz="1400" b="1" dirty="0">
+                <a:solidFill>
+                  <a:srgbClr val="16243F"/>
+                </a:solidFill>
+              </a:rPr>
+              <a:t>agendapp-rde9.onrender.com/evidencias</a:t>
+            </a:r>
+            <a:endParaRPr lang="en-US" sz="1400" dirty="0"/>
+          </a:p>
+        </p:txBody>
+      </p:sp>
+      <p:pic>
+        <p:nvPicPr>
+          <p:cNvPr id="17" name="Image 0" descr="07_admin_dashboard.png">    </p:cNvPr>
+          <p:cNvPicPr>
+            <a:picLocks noChangeAspect="1"/>
+          </p:cNvPicPr>
+          <p:nvPr/>
+        </p:nvPicPr>
+        <p:blipFill>
+          <a:blip r:embed="rId1"/>
+          <a:stretch>
+            <a:fillRect/>
+          </a:stretch>
+        </p:blipFill>
+        <p:spPr>
+          <a:xfrm>
+            <a:off x="6400800" y="1966509"/>
+            <a:ext cx="5212080" cy="3565063"/>
+          </a:xfrm>
+          <a:prstGeom prst="rect">
+            <a:avLst/>
+          </a:prstGeom>
+          <a:effectLst>
+            <a:outerShdw sx="100000" sy="100000" kx="0" ky="0" algn="bl" rotWithShape="0" blurRad="114300" dist="38100" dir="8100000">
+              <a:srgbClr val="16243F">
+                <a:alpha val="22000"/>
+              </a:srgbClr>
+            </a:outerShdw>
+          </a:effectLst>
+        </p:spPr>
+      </p:pic>
+      <p:sp>
+        <p:nvSpPr>
+          <p:cNvPr id="18" name="Text 15"/>
+          <p:cNvSpPr/>
+          <p:nvPr/>
+        </p:nvSpPr>
+        <p:spPr>
+          <a:xfrm>
+            <a:off x="548640" y="6446520"/>
+            <a:ext cx="6400800" cy="274320"/>
+          </a:xfrm>
+          <a:prstGeom prst="rect">
+            <a:avLst/>
+          </a:prstGeom>
+          <a:noFill/>
+          <a:ln/>
+        </p:spPr>
+        <p:txBody>
+          <a:bodyPr wrap="square" rtlCol="0" anchor="ctr"/>
+          <a:lstStyle/>
+          <a:p>
+            <a:pPr indent="0" marL="0">
+              <a:buNone/>
+            </a:pPr>
+            <a:r>
+              <a:rPr lang="en-US" sz="900" dirty="0">
+                <a:solidFill>
+                  <a:srgbClr val="6B7890"/>
+                </a:solidFill>
+              </a:rPr>
+              <a:t>AgendApp · Plan de Pruebas</a:t>
+            </a:r>
+            <a:endParaRPr lang="en-US" sz="900" dirty="0"/>
+          </a:p>
+        </p:txBody>
+      </p:sp>
+      <p:sp>
+        <p:nvSpPr>
+          <p:cNvPr id="19" name="Text 16"/>
+          <p:cNvSpPr/>
+          <p:nvPr/>
+        </p:nvSpPr>
+        <p:spPr>
+          <a:xfrm>
+            <a:off x="10789920" y="6446520"/>
+            <a:ext cx="914400" cy="274320"/>
+          </a:xfrm>
+          <a:prstGeom prst="rect">
+            <a:avLst/>
+          </a:prstGeom>
+          <a:noFill/>
+          <a:ln/>
+        </p:spPr>
+        <p:txBody>
+          <a:bodyPr wrap="square" rtlCol="0" anchor="ctr"/>
+          <a:lstStyle/>
+          <a:p>
+            <a:pPr algn="r" indent="0" marL="0">
+              <a:buNone/>
+            </a:pPr>
+            <a:r>
+              <a:rPr lang="en-US" sz="900" dirty="0">
+                <a:solidFill>
+                  <a:srgbClr val="6B7890"/>
+                </a:solidFill>
+              </a:rPr>
+              <a:t>10 / 11</a:t>
+            </a:r>
+            <a:endParaRPr lang="en-US" sz="900" dirty="0"/>
+          </a:p>
+        </p:txBody>
+      </p:sp>
+    </p:spTree>
+  </p:cSld>
+  <p:clrMapOvr>
+    <a:masterClrMapping/>
+  </p:clrMapOvr>
+</p:sld>
+</file>
+
+<file path=ppt/slides/slide11.xml><?xml version="1.0" encoding="utf-8"?>
+<p:sld xmlns:a="http://schemas.openxmlformats.org/drawingml/2006/main" xmlns:r="http://schemas.openxmlformats.org/officeDocument/2006/relationships" xmlns:p="http://schemas.openxmlformats.org/presentationml/2006/main">
+  <p:cSld name="Slide 11">
     <p:bg>
       <p:bgPr>
         <a:solidFill>
@@ -2449,7 +3163,7 @@
                   <a:srgbClr val="6B7890"/>
                 </a:solidFill>
               </a:rPr>
-              <a:t>2 / 10</a:t>
+              <a:t>2 / 11</a:t>
             </a:r>
             <a:endParaRPr lang="en-US" sz="900" dirty="0"/>
           </a:p>
@@ -3194,7 +3908,7 @@
                   <a:srgbClr val="6B7890"/>
                 </a:solidFill>
               </a:rPr>
-              <a:t>3 / 10</a:t>
+              <a:t>3 / 11</a:t>
             </a:r>
             <a:endParaRPr lang="en-US" sz="900" dirty="0"/>
           </a:p>
@@ -3932,7 +4646,7 @@
                   <a:srgbClr val="6B7890"/>
                 </a:solidFill>
               </a:rPr>
-              <a:t>4 / 10</a:t>
+              <a:t>4 / 11</a:t>
             </a:r>
             <a:endParaRPr lang="en-US" sz="900" dirty="0"/>
           </a:p>
@@ -5071,7 +5785,7 @@
                   <a:srgbClr val="6B7890"/>
                 </a:solidFill>
               </a:rPr>
-              <a:t>5 / 10</a:t>
+              <a:t>5 / 11</a:t>
             </a:r>
             <a:endParaRPr lang="en-US" sz="900" dirty="0"/>
           </a:p>
@@ -5713,7 +6427,7 @@
                   <a:srgbClr val="6B7890"/>
                 </a:solidFill>
               </a:rPr>
-              <a:t>6 / 10</a:t>
+              <a:t>6 / 11</a:t>
             </a:r>
             <a:endParaRPr lang="en-US" sz="900" dirty="0"/>
           </a:p>
@@ -6133,7 +6847,7 @@
                   <a:srgbClr val="6B7890"/>
                 </a:solidFill>
               </a:rPr>
-              <a:t>7 / 10</a:t>
+              <a:t>7 / 11</a:t>
             </a:r>
             <a:endParaRPr lang="en-US" sz="900" dirty="0"/>
           </a:p>
@@ -6197,7 +6911,7 @@
                 <a:ea typeface="Georgia" pitchFamily="34" charset="-122"/>
                 <a:cs typeface="Georgia" pitchFamily="34" charset="-120"/>
               </a:rPr>
-              <a:t>Evidencia: pruebas que se ejecutan de verdad</a:t>
+              <a:t>pytest: alcance y conexión con la clase</a:t>
             </a:r>
             <a:endParaRPr lang="en-US" sz="2700" dirty="0"/>
           </a:p>
@@ -6269,8 +6983,8 @@
         </p:nvSpPr>
         <p:spPr>
           <a:xfrm>
-            <a:off x="548640" y="1554480"/>
-            <a:ext cx="5486400" cy="1280160"/>
+            <a:off x="548640" y="1371600"/>
+            <a:ext cx="5486400" cy="365760"/>
           </a:xfrm>
           <a:prstGeom prst="rect">
             <a:avLst/>
@@ -6286,31 +7000,14 @@
               <a:buNone/>
             </a:pPr>
             <a:r>
-              <a:rPr lang="en-US" sz="8000" b="1" dirty="0">
-                <a:solidFill>
-                  <a:srgbClr val="1C7293"/>
-                </a:solidFill>
-                <a:latin typeface="Georgia" pitchFamily="34" charset="0"/>
-                <a:ea typeface="Georgia" pitchFamily="34" charset="-122"/>
-                <a:cs typeface="Georgia" pitchFamily="34" charset="-120"/>
-              </a:rPr>
-              <a:t>31</a:t>
-            </a:r>
-            <a:pPr indent="0" marL="0">
-              <a:buNone/>
-            </a:pPr>
-            <a:r>
-              <a:rPr lang="en-US" sz="3600" dirty="0">
-                <a:solidFill>
-                  <a:srgbClr val="6B7890"/>
-                </a:solidFill>
-                <a:latin typeface="Georgia" pitchFamily="34" charset="0"/>
-                <a:ea typeface="Georgia" pitchFamily="34" charset="-122"/>
-                <a:cs typeface="Georgia" pitchFamily="34" charset="-120"/>
-              </a:rPr>
-              <a:t> / 31</a:t>
-            </a:r>
-            <a:endParaRPr lang="en-US" sz="8000" dirty="0"/>
+              <a:rPr lang="en-US" sz="1700" b="1" dirty="0">
+                <a:solidFill>
+                  <a:srgbClr val="2E5496"/>
+                </a:solidFill>
+              </a:rPr>
+              <a:t>¿Qué es y hasta dónde llega?</a:t>
+            </a:r>
+            <a:endParaRPr lang="en-US" sz="1700" dirty="0"/>
           </a:p>
         </p:txBody>
       </p:sp>
@@ -6322,43 +7019,7 @@
         </p:nvSpPr>
         <p:spPr>
           <a:xfrm>
-            <a:off x="548640" y="2834640"/>
-            <a:ext cx="5486400" cy="365760"/>
-          </a:xfrm>
-          <a:prstGeom prst="rect">
-            <a:avLst/>
-          </a:prstGeom>
-          <a:noFill/>
-          <a:ln/>
-        </p:spPr>
-        <p:txBody>
-          <a:bodyPr wrap="square" rtlCol="0" anchor="ctr"/>
-          <a:lstStyle/>
-          <a:p>
-            <a:pPr indent="0" marL="0">
-              <a:buNone/>
-            </a:pPr>
-            <a:r>
-              <a:rPr lang="en-US" sz="1800" dirty="0">
-                <a:solidFill>
-                  <a:srgbClr val="1F2A3A"/>
-                </a:solidFill>
-              </a:rPr>
-              <a:t>pruebas superadas con pytest</a:t>
-            </a:r>
-            <a:endParaRPr lang="en-US" sz="1800" dirty="0"/>
-          </a:p>
-        </p:txBody>
-      </p:sp>
-      <p:sp>
-        <p:nvSpPr>
-          <p:cNvPr id="7" name="Text 5"/>
-          <p:cNvSpPr/>
-          <p:nvPr/>
-        </p:nvSpPr>
-        <p:spPr>
-          <a:xfrm>
-            <a:off x="548640" y="3383280"/>
+            <a:off x="548640" y="1783080"/>
             <a:ext cx="5486400" cy="1828800"/>
           </a:xfrm>
           <a:prstGeom prst="rect">
@@ -6373,81 +7034,97 @@
           <a:p>
             <a:pPr marL="342900" indent="-342900">
               <a:spcAft>
-                <a:spcPts val="800"/>
+                <a:spcPts val="600"/>
               </a:spcAft>
               <a:buSzPct val="100000"/>
               <a:buChar char="•"/>
             </a:pPr>
             <a:r>
-              <a:rPr lang="en-US" sz="1500" dirty="0">
+              <a:rPr lang="en-US" sz="1350" dirty="0">
                 <a:solidFill>
                   <a:srgbClr val="1F2A3A"/>
                 </a:solidFill>
               </a:rPr>
-              <a:t>15 de autenticación · 16 de citas, API y motor IA</a:t>
-            </a:r>
-            <a:endParaRPr lang="en-US" sz="1500" dirty="0"/>
+              <a:t>Framework de pruebas de Python: ejecuta y reporta solo.</a:t>
+            </a:r>
+            <a:endParaRPr lang="en-US" sz="1350" dirty="0"/>
           </a:p>
           <a:p>
             <a:pPr marL="342900" indent="-342900">
               <a:spcAft>
-                <a:spcPts val="800"/>
+                <a:spcPts val="600"/>
               </a:spcAft>
               <a:buSzPct val="100000"/>
               <a:buChar char="•"/>
             </a:pPr>
             <a:r>
-              <a:rPr lang="en-US" sz="1500" dirty="0">
+              <a:rPr lang="en-US" sz="1350" dirty="0">
                 <a:solidFill>
                   <a:srgbClr val="1F2A3A"/>
                 </a:solidFill>
               </a:rPr>
-              <a:t>Página pública de evidencias dentro de la app</a:t>
-            </a:r>
-            <a:endParaRPr lang="en-US" sz="1500" dirty="0"/>
+              <a:t>Alcance: una misma suite cubre los niveles unitario, integración y sistema.</a:t>
+            </a:r>
+            <a:endParaRPr lang="en-US" sz="1350" dirty="0"/>
           </a:p>
           <a:p>
             <a:pPr marL="342900" indent="-342900">
               <a:spcAft>
-                <a:spcPts val="800"/>
+                <a:spcPts val="600"/>
               </a:spcAft>
               <a:buSzPct val="100000"/>
               <a:buChar char="•"/>
             </a:pPr>
             <a:r>
-              <a:rPr lang="en-US" sz="1500" dirty="0">
+              <a:rPr lang="en-US" sz="1350" dirty="0">
                 <a:solidFill>
                   <a:srgbClr val="1F2A3A"/>
                 </a:solidFill>
               </a:rPr>
-              <a:t>github.com/bgaleanotec-maker/agendapp</a:t>
-            </a:r>
-            <a:endParaRPr lang="en-US" sz="1500" dirty="0"/>
-          </a:p>
-        </p:txBody>
-      </p:sp>
-      <p:pic>
-        <p:nvPicPr>
-          <p:cNvPr id="8" name="Image 0" descr="02_evidencias.png">    </p:cNvPr>
-          <p:cNvPicPr>
-            <a:picLocks noChangeAspect="1"/>
-          </p:cNvPicPr>
-          <p:nvPr/>
-        </p:nvPicPr>
-        <p:blipFill>
-          <a:blip r:embed="rId1"/>
-          <a:stretch>
-            <a:fillRect/>
-          </a:stretch>
-        </p:blipFill>
-        <p:spPr>
-          <a:xfrm>
-            <a:off x="7575459" y="1417320"/>
-            <a:ext cx="2862762" cy="4663440"/>
-          </a:xfrm>
-          <a:prstGeom prst="rect">
-            <a:avLst/>
-          </a:prstGeom>
+              <a:t>Fixtures (conftest.py): entorno aislado y reproducible con BD en memoria.</a:t>
+            </a:r>
+            <a:endParaRPr lang="en-US" sz="1350" dirty="0"/>
+          </a:p>
+          <a:p>
+            <a:pPr marL="342900" indent="-342900">
+              <a:spcAft>
+                <a:spcPts val="600"/>
+              </a:spcAft>
+              <a:buSzPct val="100000"/>
+              <a:buChar char="•"/>
+            </a:pPr>
+            <a:r>
+              <a:rPr lang="en-US" sz="1350" dirty="0">
+                <a:solidFill>
+                  <a:srgbClr val="1F2A3A"/>
+                </a:solidFill>
+              </a:rPr>
+              <a:t>Cobertura con pytest-cov; se corre en cada cambio.</a:t>
+            </a:r>
+            <a:endParaRPr lang="en-US" sz="1350" dirty="0"/>
+          </a:p>
+        </p:txBody>
+      </p:sp>
+      <p:sp>
+        <p:nvSpPr>
+          <p:cNvPr id="7" name="Shape 5"/>
+          <p:cNvSpPr/>
+          <p:nvPr/>
+        </p:nvSpPr>
+        <p:spPr>
+          <a:xfrm>
+            <a:off x="548640" y="3794760"/>
+            <a:ext cx="5486400" cy="2011680"/>
+          </a:xfrm>
+          <a:prstGeom prst="roundRect">
+            <a:avLst>
+              <a:gd name="adj" fmla="val 3636"/>
+            </a:avLst>
+          </a:prstGeom>
+          <a:solidFill>
+            <a:srgbClr val="0E1B33"/>
+          </a:solidFill>
+          <a:ln/>
           <a:effectLst>
             <a:outerShdw sx="100000" sy="100000" kx="0" ky="0" algn="bl" rotWithShape="0" blurRad="114300" dist="38100" dir="8100000">
               <a:srgbClr val="16243F">
@@ -6456,10 +7133,295 @@
             </a:outerShdw>
           </a:effectLst>
         </p:spPr>
-      </p:pic>
-      <p:sp>
-        <p:nvSpPr>
-          <p:cNvPr id="9" name="Text 6"/>
+      </p:sp>
+      <p:sp>
+        <p:nvSpPr>
+          <p:cNvPr id="8" name="Text 6"/>
+          <p:cNvSpPr/>
+          <p:nvPr/>
+        </p:nvSpPr>
+        <p:spPr>
+          <a:xfrm>
+            <a:off x="548640" y="3794760"/>
+            <a:ext cx="5486400" cy="2011680"/>
+          </a:xfrm>
+          <a:prstGeom prst="rect">
+            <a:avLst/>
+          </a:prstGeom>
+          <a:noFill/>
+          <a:ln/>
+        </p:spPr>
+        <p:txBody>
+          <a:bodyPr wrap="square" lIns="127000" tIns="127000" rIns="127000" bIns="127000" rtlCol="0" anchor="ctr"/>
+          <a:lstStyle/>
+          <a:p>
+            <a:pPr indent="0" marL="0">
+              <a:buNone/>
+            </a:pPr>
+            <a:r>
+              <a:rPr lang="en-US" sz="1200" b="1" dirty="0">
+                <a:solidFill>
+                  <a:srgbClr val="C792EA"/>
+                </a:solidFill>
+                <a:latin typeface="Consolas" pitchFamily="34" charset="0"/>
+                <a:ea typeface="Consolas" pitchFamily="34" charset="-122"/>
+                <a:cs typeface="Consolas" pitchFamily="34" charset="-120"/>
+              </a:rPr>
+              <a:t>class </a:t>
+            </a:r>
+            <a:pPr indent="0" marL="0">
+              <a:buNone/>
+            </a:pPr>
+            <a:r>
+              <a:rPr lang="en-US" sz="1200" dirty="0">
+                <a:solidFill>
+                  <a:srgbClr val="D6E7FF"/>
+                </a:solidFill>
+                <a:latin typeface="Consolas" pitchFamily="34" charset="0"/>
+                <a:ea typeface="Consolas" pitchFamily="34" charset="-122"/>
+                <a:cs typeface="Consolas" pitchFamily="34" charset="-120"/>
+              </a:rPr>
+              <a:t>TestMotorIA:</a:t>
+            </a:r>
+            <a:pPr indent="0" marL="0">
+              <a:buNone/>
+            </a:pPr>
+            <a:r>
+              <a:rPr lang="en-US" sz="1200" b="1" dirty="0">
+                <a:solidFill>
+                  <a:srgbClr val="C792EA"/>
+                </a:solidFill>
+                <a:latin typeface="Consolas" pitchFamily="34" charset="0"/>
+                <a:ea typeface="Consolas" pitchFamily="34" charset="-122"/>
+                <a:cs typeface="Consolas" pitchFamily="34" charset="-120"/>
+              </a:rPr>
+              <a:t>  def </a:t>
+            </a:r>
+            <a:pPr indent="0" marL="0">
+              <a:buNone/>
+            </a:pPr>
+            <a:r>
+              <a:rPr lang="en-US" sz="1200" dirty="0">
+                <a:solidFill>
+                  <a:srgbClr val="D6E7FF"/>
+                </a:solidFill>
+                <a:latin typeface="Consolas" pitchFamily="34" charset="0"/>
+                <a:ea typeface="Consolas" pitchFamily="34" charset="-122"/>
+                <a:cs typeface="Consolas" pitchFamily="34" charset="-120"/>
+              </a:rPr>
+              <a:t>test_prescreen_urgente(self, client):</a:t>
+            </a:r>
+            <a:pPr indent="0" marL="0">
+              <a:buNone/>
+            </a:pPr>
+            <a:r>
+              <a:rPr lang="en-US" sz="1200" dirty="0">
+                <a:solidFill>
+                  <a:srgbClr val="9FE7D4"/>
+                </a:solidFill>
+                <a:latin typeface="Consolas" pitchFamily="34" charset="0"/>
+                <a:ea typeface="Consolas" pitchFamily="34" charset="-122"/>
+                <a:cs typeface="Consolas" pitchFamily="34" charset="-120"/>
+              </a:rPr>
+              <a:t>    r = client.post("/api/ai/prescreen",</a:t>
+            </a:r>
+            <a:pPr indent="0" marL="0">
+              <a:buNone/>
+            </a:pPr>
+            <a:r>
+              <a:rPr lang="en-US" sz="1200" dirty="0">
+                <a:solidFill>
+                  <a:srgbClr val="9FE7D4"/>
+                </a:solidFill>
+                <a:latin typeface="Consolas" pitchFamily="34" charset="0"/>
+                <a:ea typeface="Consolas" pitchFamily="34" charset="-122"/>
+                <a:cs typeface="Consolas" pitchFamily="34" charset="-120"/>
+              </a:rPr>
+              <a:t>        json={"text": "dolor pecho ..."})</a:t>
+            </a:r>
+            <a:pPr indent="0" marL="0">
+              <a:buNone/>
+            </a:pPr>
+            <a:r>
+              <a:rPr lang="en-US" sz="1200" b="1" dirty="0">
+                <a:solidFill>
+                  <a:srgbClr val="C792EA"/>
+                </a:solidFill>
+                <a:latin typeface="Consolas" pitchFamily="34" charset="0"/>
+                <a:ea typeface="Consolas" pitchFamily="34" charset="-122"/>
+                <a:cs typeface="Consolas" pitchFamily="34" charset="-120"/>
+              </a:rPr>
+              <a:t>    assert </a:t>
+            </a:r>
+            <a:pPr indent="0" marL="0">
+              <a:buNone/>
+            </a:pPr>
+            <a:r>
+              <a:rPr lang="en-US" sz="1200" dirty="0">
+                <a:solidFill>
+                  <a:srgbClr val="D6E7FF"/>
+                </a:solidFill>
+                <a:latin typeface="Consolas" pitchFamily="34" charset="0"/>
+                <a:ea typeface="Consolas" pitchFamily="34" charset="-122"/>
+                <a:cs typeface="Consolas" pitchFamily="34" charset="-120"/>
+              </a:rPr>
+              <a:t>r.get_json()["level"] == "urgente"</a:t>
+            </a:r>
+            <a:endParaRPr lang="en-US" sz="1200" dirty="0"/>
+          </a:p>
+        </p:txBody>
+      </p:sp>
+      <p:sp>
+        <p:nvSpPr>
+          <p:cNvPr id="9" name="Text 7"/>
+          <p:cNvSpPr/>
+          <p:nvPr/>
+        </p:nvSpPr>
+        <p:spPr>
+          <a:xfrm>
+            <a:off x="6400800" y="1371600"/>
+            <a:ext cx="5212080" cy="365760"/>
+          </a:xfrm>
+          <a:prstGeom prst="rect">
+            <a:avLst/>
+          </a:prstGeom>
+          <a:noFill/>
+          <a:ln/>
+        </p:spPr>
+        <p:txBody>
+          <a:bodyPr wrap="square" rtlCol="0" anchor="ctr"/>
+          <a:lstStyle/>
+          <a:p>
+            <a:pPr indent="0" marL="0">
+              <a:buNone/>
+            </a:pPr>
+            <a:r>
+              <a:rPr lang="en-US" sz="1700" b="1" dirty="0">
+                <a:solidFill>
+                  <a:srgbClr val="2E5496"/>
+                </a:solidFill>
+              </a:rPr>
+              <a:t>Cómo conecta con lo visto en clase</a:t>
+            </a:r>
+            <a:endParaRPr lang="en-US" sz="1700" dirty="0"/>
+          </a:p>
+        </p:txBody>
+      </p:sp>
+      <p:sp>
+        <p:nvSpPr>
+          <p:cNvPr id="10" name="Text 8"/>
+          <p:cNvSpPr/>
+          <p:nvPr/>
+        </p:nvSpPr>
+        <p:spPr>
+          <a:xfrm>
+            <a:off x="6400800" y="1783080"/>
+            <a:ext cx="5212080" cy="4023360"/>
+          </a:xfrm>
+          <a:prstGeom prst="rect">
+            <a:avLst/>
+          </a:prstGeom>
+          <a:noFill/>
+          <a:ln/>
+        </p:spPr>
+        <p:txBody>
+          <a:bodyPr wrap="square" rtlCol="0" anchor="ctr"/>
+          <a:lstStyle/>
+          <a:p>
+            <a:pPr marL="342900" indent="-342900">
+              <a:spcAft>
+                <a:spcPts val="1000"/>
+              </a:spcAft>
+              <a:buSzPct val="100000"/>
+              <a:buChar char="•"/>
+            </a:pPr>
+            <a:r>
+              <a:rPr lang="en-US" sz="1400" dirty="0">
+                <a:solidFill>
+                  <a:srgbClr val="1F2A3A"/>
+                </a:solidFill>
+              </a:rPr>
+              <a:t>Modelo V: un comando ejercita unitario → integración → sistema.</a:t>
+            </a:r>
+            <a:endParaRPr lang="en-US" sz="1400" dirty="0"/>
+          </a:p>
+          <a:p>
+            <a:pPr marL="342900" indent="-342900">
+              <a:spcAft>
+                <a:spcPts val="1000"/>
+              </a:spcAft>
+              <a:buSzPct val="100000"/>
+              <a:buChar char="•"/>
+            </a:pPr>
+            <a:r>
+              <a:rPr lang="en-US" sz="1400" dirty="0">
+                <a:solidFill>
+                  <a:srgbClr val="1F2A3A"/>
+                </a:solidFill>
+              </a:rPr>
+              <a:t>Automatización → regresión: red de seguridad ante cada cambio.</a:t>
+            </a:r>
+            <a:endParaRPr lang="en-US" sz="1400" dirty="0"/>
+          </a:p>
+          <a:p>
+            <a:pPr marL="342900" indent="-342900">
+              <a:spcAft>
+                <a:spcPts val="1000"/>
+              </a:spcAft>
+              <a:buSzPct val="100000"/>
+              <a:buChar char="•"/>
+            </a:pPr>
+            <a:r>
+              <a:rPr lang="en-US" sz="1400" dirty="0">
+                <a:solidFill>
+                  <a:srgbClr val="1F2A3A"/>
+                </a:solidFill>
+              </a:rPr>
+              <a:t>Entorno controlado y reproducible, condición de una prueba confiable (Singh, 2011).</a:t>
+            </a:r>
+            <a:endParaRPr lang="en-US" sz="1400" dirty="0"/>
+          </a:p>
+          <a:p>
+            <a:pPr marL="342900" indent="-342900">
+              <a:spcAft>
+                <a:spcPts val="1000"/>
+              </a:spcAft>
+              <a:buSzPct val="100000"/>
+              <a:buChar char="•"/>
+            </a:pPr>
+            <a:r>
+              <a:rPr lang="en-US" sz="1400" dirty="0">
+                <a:solidFill>
+                  <a:srgbClr val="1F2A3A"/>
+                </a:solidFill>
+              </a:rPr>
+              <a:t>Técnicas de diseño (partición, valores límite, decisión) en cada caso.</a:t>
+            </a:r>
+            <a:endParaRPr lang="en-US" sz="1400" dirty="0"/>
+          </a:p>
+          <a:p>
+            <a:pPr marL="342900" indent="-342900">
+              <a:spcAft>
+                <a:spcPts val="1000"/>
+              </a:spcAft>
+              <a:buSzPct val="100000"/>
+              <a:buChar char="•"/>
+            </a:pPr>
+            <a:r>
+              <a:rPr lang="en-US" sz="1400" dirty="0">
+                <a:solidFill>
+                  <a:srgbClr val="1F2A3A"/>
+                </a:solidFill>
+              </a:rPr>
+              <a:t>Verificación y validación llevadas a la práctica (SWEBOK).</a:t>
+            </a:r>
+            <a:endParaRPr lang="en-US" sz="1400" dirty="0"/>
+          </a:p>
+        </p:txBody>
+      </p:sp>
+      <p:sp>
+        <p:nvSpPr>
+          <p:cNvPr id="11" name="Text 9"/>
           <p:cNvSpPr/>
           <p:nvPr/>
         </p:nvSpPr>
@@ -6495,7 +7457,7 @@
       </p:sp>
       <p:sp>
         <p:nvSpPr>
-          <p:cNvPr id="10" name="Text 7"/>
+          <p:cNvPr id="12" name="Text 10"/>
           <p:cNvSpPr/>
           <p:nvPr/>
         </p:nvSpPr>
@@ -6523,7 +7485,7 @@
                   <a:srgbClr val="6B7890"/>
                 </a:solidFill>
               </a:rPr>
-              <a:t>8 / 10</a:t>
+              <a:t>8 / 11</a:t>
             </a:r>
             <a:endParaRPr lang="en-US" sz="900" dirty="0"/>
           </a:p>
@@ -6587,7 +7549,7 @@
                 <a:ea typeface="Georgia" pitchFamily="34" charset="-122"/>
                 <a:cs typeface="Georgia" pitchFamily="34" charset="-120"/>
               </a:rPr>
-              <a:t>Modo demo para validación del docente</a:t>
+              <a:t>Evidencia: pruebas que se ejecutan de verdad</a:t>
             </a:r>
             <a:endParaRPr lang="en-US" sz="2700" dirty="0"/>
           </a:p>
@@ -6645,7 +7607,7 @@
                   <a:srgbClr val="06281F"/>
                 </a:solidFill>
               </a:rPr>
-              <a:t>Brayan / Todos</a:t>
+              <a:t>Brayan</a:t>
             </a:r>
             <a:endParaRPr lang="en-US" sz="1300" dirty="0"/>
           </a:p>
@@ -6659,8 +7621,8 @@
         </p:nvSpPr>
         <p:spPr>
           <a:xfrm>
-            <a:off x="548640" y="1463040"/>
-            <a:ext cx="5669280" cy="457200"/>
+            <a:off x="548640" y="1554480"/>
+            <a:ext cx="5486400" cy="1280160"/>
           </a:xfrm>
           <a:prstGeom prst="rect">
             <a:avLst/>
@@ -6676,43 +7638,69 @@
               <a:buNone/>
             </a:pPr>
             <a:r>
-              <a:rPr lang="en-US" sz="1700" dirty="0">
+              <a:rPr lang="en-US" sz="8000" b="1" dirty="0">
+                <a:solidFill>
+                  <a:srgbClr val="1C7293"/>
+                </a:solidFill>
+                <a:latin typeface="Georgia" pitchFamily="34" charset="0"/>
+                <a:ea typeface="Georgia" pitchFamily="34" charset="-122"/>
+                <a:cs typeface="Georgia" pitchFamily="34" charset="-120"/>
+              </a:rPr>
+              <a:t>31</a:t>
+            </a:r>
+            <a:pPr indent="0" marL="0">
+              <a:buNone/>
+            </a:pPr>
+            <a:r>
+              <a:rPr lang="en-US" sz="3600" dirty="0">
+                <a:solidFill>
+                  <a:srgbClr val="6B7890"/>
+                </a:solidFill>
+                <a:latin typeface="Georgia" pitchFamily="34" charset="0"/>
+                <a:ea typeface="Georgia" pitchFamily="34" charset="-122"/>
+                <a:cs typeface="Georgia" pitchFamily="34" charset="-120"/>
+              </a:rPr>
+              <a:t> / 31</a:t>
+            </a:r>
+            <a:endParaRPr lang="en-US" sz="8000" dirty="0"/>
+          </a:p>
+        </p:txBody>
+      </p:sp>
+      <p:sp>
+        <p:nvSpPr>
+          <p:cNvPr id="6" name="Text 4"/>
+          <p:cNvSpPr/>
+          <p:nvPr/>
+        </p:nvSpPr>
+        <p:spPr>
+          <a:xfrm>
+            <a:off x="548640" y="2834640"/>
+            <a:ext cx="5486400" cy="365760"/>
+          </a:xfrm>
+          <a:prstGeom prst="rect">
+            <a:avLst/>
+          </a:prstGeom>
+          <a:noFill/>
+          <a:ln/>
+        </p:spPr>
+        <p:txBody>
+          <a:bodyPr wrap="square" rtlCol="0" anchor="ctr"/>
+          <a:lstStyle/>
+          <a:p>
+            <a:pPr indent="0" marL="0">
+              <a:buNone/>
+            </a:pPr>
+            <a:r>
+              <a:rPr lang="en-US" sz="1800" dirty="0">
                 <a:solidFill>
                   <a:srgbClr val="1F2A3A"/>
                 </a:solidFill>
               </a:rPr>
-              <a:t>El docente puede validar las pruebas sin instalar nada.</a:t>
-            </a:r>
-            <a:endParaRPr lang="en-US" sz="1700" dirty="0"/>
-          </a:p>
-        </p:txBody>
-      </p:sp>
-      <p:sp>
-        <p:nvSpPr>
-          <p:cNvPr id="6" name="Shape 4"/>
-          <p:cNvSpPr/>
-          <p:nvPr/>
-        </p:nvSpPr>
-        <p:spPr>
-          <a:xfrm>
-            <a:off x="548640" y="2103120"/>
-            <a:ext cx="5669280" cy="640080"/>
-          </a:xfrm>
-          <a:prstGeom prst="roundRect">
-            <a:avLst>
-              <a:gd name="adj" fmla="val 11429"/>
-            </a:avLst>
-          </a:prstGeom>
-          <a:solidFill>
-            <a:srgbClr val="FFFFFF"/>
-          </a:solidFill>
-          <a:ln w="12700">
-            <a:solidFill>
-              <a:srgbClr val="D5DEEC"/>
-            </a:solidFill>
-            <a:prstDash val="solid"/>
-          </a:ln>
-        </p:spPr>
+              <a:t>pruebas superadas con pytest</a:t>
+            </a:r>
+            <a:endParaRPr lang="en-US" sz="1800" dirty="0"/>
+          </a:p>
+        </p:txBody>
       </p:sp>
       <p:sp>
         <p:nvSpPr>
@@ -6722,338 +7710,77 @@
         </p:nvSpPr>
         <p:spPr>
           <a:xfrm>
-            <a:off x="731520" y="2103120"/>
-            <a:ext cx="1828800" cy="640080"/>
-          </a:xfrm>
-          <a:prstGeom prst="rect">
-            <a:avLst/>
-          </a:prstGeom>
-          <a:noFill/>
-          <a:ln/>
-        </p:spPr>
-        <p:txBody>
-          <a:bodyPr wrap="square" rtlCol="0" anchor="ctr"/>
-          <a:lstStyle/>
-          <a:p>
-            <a:pPr indent="0" marL="0">
-              <a:buNone/>
-            </a:pPr>
-            <a:r>
-              <a:rPr lang="en-US" sz="1400" b="1" dirty="0">
-                <a:solidFill>
-                  <a:srgbClr val="16243F"/>
-                </a:solidFill>
-              </a:rPr>
-              <a:t>Docente (admin)</a:t>
-            </a:r>
-            <a:endParaRPr lang="en-US" sz="1400" dirty="0"/>
-          </a:p>
-        </p:txBody>
-      </p:sp>
-      <p:sp>
-        <p:nvSpPr>
-          <p:cNvPr id="8" name="Text 6"/>
-          <p:cNvSpPr/>
-          <p:nvPr/>
-        </p:nvSpPr>
-        <p:spPr>
-          <a:xfrm>
-            <a:off x="2468880" y="2103120"/>
-            <a:ext cx="3657600" cy="640080"/>
-          </a:xfrm>
-          <a:prstGeom prst="rect">
-            <a:avLst/>
-          </a:prstGeom>
-          <a:noFill/>
-          <a:ln/>
-        </p:spPr>
-        <p:txBody>
-          <a:bodyPr wrap="square" rtlCol="0" anchor="ctr"/>
-          <a:lstStyle/>
-          <a:p>
-            <a:pPr indent="0" marL="0">
-              <a:buNone/>
-            </a:pPr>
-            <a:r>
-              <a:rPr lang="en-US" sz="1300" dirty="0">
-                <a:solidFill>
-                  <a:srgbClr val="1C7293"/>
-                </a:solidFill>
-                <a:latin typeface="Consolas" pitchFamily="34" charset="0"/>
-                <a:ea typeface="Consolas" pitchFamily="34" charset="-122"/>
-                <a:cs typeface="Consolas" pitchFamily="34" charset="-120"/>
-              </a:rPr>
-              <a:t>docente@agendapp.co · Demo2026!</a:t>
-            </a:r>
-            <a:endParaRPr lang="en-US" sz="1300" dirty="0"/>
-          </a:p>
-        </p:txBody>
-      </p:sp>
-      <p:sp>
-        <p:nvSpPr>
-          <p:cNvPr id="9" name="Shape 7"/>
-          <p:cNvSpPr/>
-          <p:nvPr/>
-        </p:nvSpPr>
-        <p:spPr>
-          <a:xfrm>
-            <a:off x="548640" y="2880360"/>
-            <a:ext cx="5669280" cy="640080"/>
-          </a:xfrm>
-          <a:prstGeom prst="roundRect">
-            <a:avLst>
-              <a:gd name="adj" fmla="val 11429"/>
-            </a:avLst>
-          </a:prstGeom>
-          <a:solidFill>
-            <a:srgbClr val="FFFFFF"/>
-          </a:solidFill>
-          <a:ln w="12700">
-            <a:solidFill>
-              <a:srgbClr val="D5DEEC"/>
-            </a:solidFill>
-            <a:prstDash val="solid"/>
-          </a:ln>
-        </p:spPr>
-      </p:sp>
-      <p:sp>
-        <p:nvSpPr>
-          <p:cNvPr id="10" name="Text 8"/>
-          <p:cNvSpPr/>
-          <p:nvPr/>
-        </p:nvSpPr>
-        <p:spPr>
-          <a:xfrm>
-            <a:off x="731520" y="2880360"/>
-            <a:ext cx="1828800" cy="640080"/>
-          </a:xfrm>
-          <a:prstGeom prst="rect">
-            <a:avLst/>
-          </a:prstGeom>
-          <a:noFill/>
-          <a:ln/>
-        </p:spPr>
-        <p:txBody>
-          <a:bodyPr wrap="square" rtlCol="0" anchor="ctr"/>
-          <a:lstStyle/>
-          <a:p>
-            <a:pPr indent="0" marL="0">
-              <a:buNone/>
-            </a:pPr>
-            <a:r>
-              <a:rPr lang="en-US" sz="1400" b="1" dirty="0">
-                <a:solidFill>
-                  <a:srgbClr val="16243F"/>
-                </a:solidFill>
-              </a:rPr>
-              <a:t>Médico</a:t>
-            </a:r>
-            <a:endParaRPr lang="en-US" sz="1400" dirty="0"/>
-          </a:p>
-        </p:txBody>
-      </p:sp>
-      <p:sp>
-        <p:nvSpPr>
-          <p:cNvPr id="11" name="Text 9"/>
-          <p:cNvSpPr/>
-          <p:nvPr/>
-        </p:nvSpPr>
-        <p:spPr>
-          <a:xfrm>
-            <a:off x="2468880" y="2880360"/>
-            <a:ext cx="3657600" cy="640080"/>
-          </a:xfrm>
-          <a:prstGeom prst="rect">
-            <a:avLst/>
-          </a:prstGeom>
-          <a:noFill/>
-          <a:ln/>
-        </p:spPr>
-        <p:txBody>
-          <a:bodyPr wrap="square" rtlCol="0" anchor="ctr"/>
-          <a:lstStyle/>
-          <a:p>
-            <a:pPr indent="0" marL="0">
-              <a:buNone/>
-            </a:pPr>
-            <a:r>
-              <a:rPr lang="en-US" sz="1300" dirty="0">
-                <a:solidFill>
-                  <a:srgbClr val="1C7293"/>
-                </a:solidFill>
-                <a:latin typeface="Consolas" pitchFamily="34" charset="0"/>
-                <a:ea typeface="Consolas" pitchFamily="34" charset="-122"/>
-                <a:cs typeface="Consolas" pitchFamily="34" charset="-120"/>
-              </a:rPr>
-              <a:t>dr.garcia@agendapp.co · Doctor2024!</a:t>
-            </a:r>
-            <a:endParaRPr lang="en-US" sz="1300" dirty="0"/>
-          </a:p>
-        </p:txBody>
-      </p:sp>
-      <p:sp>
-        <p:nvSpPr>
-          <p:cNvPr id="12" name="Shape 10"/>
-          <p:cNvSpPr/>
-          <p:nvPr/>
-        </p:nvSpPr>
-        <p:spPr>
-          <a:xfrm>
-            <a:off x="548640" y="3657600"/>
-            <a:ext cx="5669280" cy="640080"/>
-          </a:xfrm>
-          <a:prstGeom prst="roundRect">
-            <a:avLst>
-              <a:gd name="adj" fmla="val 11429"/>
-            </a:avLst>
-          </a:prstGeom>
-          <a:solidFill>
-            <a:srgbClr val="FFFFFF"/>
-          </a:solidFill>
-          <a:ln w="12700">
-            <a:solidFill>
-              <a:srgbClr val="D5DEEC"/>
-            </a:solidFill>
-            <a:prstDash val="solid"/>
-          </a:ln>
-        </p:spPr>
-      </p:sp>
-      <p:sp>
-        <p:nvSpPr>
-          <p:cNvPr id="13" name="Text 11"/>
-          <p:cNvSpPr/>
-          <p:nvPr/>
-        </p:nvSpPr>
-        <p:spPr>
-          <a:xfrm>
-            <a:off x="731520" y="3657600"/>
-            <a:ext cx="1828800" cy="640080"/>
-          </a:xfrm>
-          <a:prstGeom prst="rect">
-            <a:avLst/>
-          </a:prstGeom>
-          <a:noFill/>
-          <a:ln/>
-        </p:spPr>
-        <p:txBody>
-          <a:bodyPr wrap="square" rtlCol="0" anchor="ctr"/>
-          <a:lstStyle/>
-          <a:p>
-            <a:pPr indent="0" marL="0">
-              <a:buNone/>
-            </a:pPr>
-            <a:r>
-              <a:rPr lang="en-US" sz="1400" b="1" dirty="0">
-                <a:solidFill>
-                  <a:srgbClr val="16243F"/>
-                </a:solidFill>
-              </a:rPr>
-              <a:t>Paciente</a:t>
-            </a:r>
-            <a:endParaRPr lang="en-US" sz="1400" dirty="0"/>
-          </a:p>
-        </p:txBody>
-      </p:sp>
-      <p:sp>
-        <p:nvSpPr>
-          <p:cNvPr id="14" name="Text 12"/>
-          <p:cNvSpPr/>
-          <p:nvPr/>
-        </p:nvSpPr>
-        <p:spPr>
-          <a:xfrm>
-            <a:off x="2468880" y="3657600"/>
-            <a:ext cx="3657600" cy="640080"/>
-          </a:xfrm>
-          <a:prstGeom prst="rect">
-            <a:avLst/>
-          </a:prstGeom>
-          <a:noFill/>
-          <a:ln/>
-        </p:spPr>
-        <p:txBody>
-          <a:bodyPr wrap="square" rtlCol="0" anchor="ctr"/>
-          <a:lstStyle/>
-          <a:p>
-            <a:pPr indent="0" marL="0">
-              <a:buNone/>
-            </a:pPr>
-            <a:r>
-              <a:rPr lang="en-US" sz="1300" dirty="0">
-                <a:solidFill>
-                  <a:srgbClr val="1C7293"/>
-                </a:solidFill>
-                <a:latin typeface="Consolas" pitchFamily="34" charset="0"/>
-                <a:ea typeface="Consolas" pitchFamily="34" charset="-122"/>
-                <a:cs typeface="Consolas" pitchFamily="34" charset="-120"/>
-              </a:rPr>
-              <a:t>maria@test.co · Paciente2024!</a:t>
-            </a:r>
-            <a:endParaRPr lang="en-US" sz="1300" dirty="0"/>
-          </a:p>
-        </p:txBody>
-      </p:sp>
-      <p:sp>
-        <p:nvSpPr>
-          <p:cNvPr id="15" name="Shape 13"/>
-          <p:cNvSpPr/>
-          <p:nvPr/>
-        </p:nvSpPr>
-        <p:spPr>
-          <a:xfrm>
-            <a:off x="548640" y="4617720"/>
-            <a:ext cx="5669280" cy="548640"/>
-          </a:xfrm>
-          <a:prstGeom prst="roundRect">
-            <a:avLst>
-              <a:gd name="adj" fmla="val 13333"/>
-            </a:avLst>
-          </a:prstGeom>
-          <a:solidFill>
-            <a:srgbClr val="F1F5FC"/>
-          </a:solidFill>
-          <a:ln/>
-        </p:spPr>
-      </p:sp>
-      <p:sp>
-        <p:nvSpPr>
-          <p:cNvPr id="16" name="Text 14"/>
-          <p:cNvSpPr/>
-          <p:nvPr/>
-        </p:nvSpPr>
-        <p:spPr>
-          <a:xfrm>
-            <a:off x="548640" y="4617720"/>
-            <a:ext cx="5669280" cy="548640"/>
-          </a:xfrm>
-          <a:prstGeom prst="rect">
-            <a:avLst/>
-          </a:prstGeom>
-          <a:noFill/>
-          <a:ln/>
-        </p:spPr>
-        <p:txBody>
-          <a:bodyPr wrap="square" rtlCol="0" anchor="ctr"/>
-          <a:lstStyle/>
-          <a:p>
-            <a:pPr algn="ctr" indent="0" marL="0">
-              <a:buNone/>
-            </a:pPr>
-            <a:r>
-              <a:rPr lang="en-US" sz="1400" b="1" dirty="0">
-                <a:solidFill>
-                  <a:srgbClr val="16243F"/>
-                </a:solidFill>
-              </a:rPr>
-              <a:t>agendapp-rde9.onrender.com/evidencias</a:t>
-            </a:r>
-            <a:endParaRPr lang="en-US" sz="1400" dirty="0"/>
+            <a:off x="548640" y="3383280"/>
+            <a:ext cx="5486400" cy="1828800"/>
+          </a:xfrm>
+          <a:prstGeom prst="rect">
+            <a:avLst/>
+          </a:prstGeom>
+          <a:noFill/>
+          <a:ln/>
+        </p:spPr>
+        <p:txBody>
+          <a:bodyPr wrap="square" rtlCol="0" anchor="ctr"/>
+          <a:lstStyle/>
+          <a:p>
+            <a:pPr marL="342900" indent="-342900">
+              <a:spcAft>
+                <a:spcPts val="800"/>
+              </a:spcAft>
+              <a:buSzPct val="100000"/>
+              <a:buChar char="•"/>
+            </a:pPr>
+            <a:r>
+              <a:rPr lang="en-US" sz="1500" dirty="0">
+                <a:solidFill>
+                  <a:srgbClr val="1F2A3A"/>
+                </a:solidFill>
+              </a:rPr>
+              <a:t>15 de autenticación · 16 de citas, API y motor IA</a:t>
+            </a:r>
+            <a:endParaRPr lang="en-US" sz="1500" dirty="0"/>
+          </a:p>
+          <a:p>
+            <a:pPr marL="342900" indent="-342900">
+              <a:spcAft>
+                <a:spcPts val="800"/>
+              </a:spcAft>
+              <a:buSzPct val="100000"/>
+              <a:buChar char="•"/>
+            </a:pPr>
+            <a:r>
+              <a:rPr lang="en-US" sz="1500" dirty="0">
+                <a:solidFill>
+                  <a:srgbClr val="1F2A3A"/>
+                </a:solidFill>
+              </a:rPr>
+              <a:t>Página pública de evidencias dentro de la app</a:t>
+            </a:r>
+            <a:endParaRPr lang="en-US" sz="1500" dirty="0"/>
+          </a:p>
+          <a:p>
+            <a:pPr marL="342900" indent="-342900">
+              <a:spcAft>
+                <a:spcPts val="800"/>
+              </a:spcAft>
+              <a:buSzPct val="100000"/>
+              <a:buChar char="•"/>
+            </a:pPr>
+            <a:r>
+              <a:rPr lang="en-US" sz="1500" dirty="0">
+                <a:solidFill>
+                  <a:srgbClr val="1F2A3A"/>
+                </a:solidFill>
+              </a:rPr>
+              <a:t>github.com/bgaleanotec-maker/agendapp</a:t>
+            </a:r>
+            <a:endParaRPr lang="en-US" sz="1500" dirty="0"/>
           </a:p>
         </p:txBody>
       </p:sp>
       <p:pic>
         <p:nvPicPr>
-          <p:cNvPr id="17" name="Image 0" descr="07_admin_dashboard.png">    </p:cNvPr>
+          <p:cNvPr id="8" name="Image 0" descr="02_evidencias.png">    </p:cNvPr>
           <p:cNvPicPr>
             <a:picLocks noChangeAspect="1"/>
           </p:cNvPicPr>
@@ -7067,8 +7794,8 @@
         </p:blipFill>
         <p:spPr>
           <a:xfrm>
-            <a:off x="6400800" y="1966509"/>
-            <a:ext cx="5212080" cy="3565063"/>
+            <a:off x="7575459" y="1417320"/>
+            <a:ext cx="2862762" cy="4663440"/>
           </a:xfrm>
           <a:prstGeom prst="rect">
             <a:avLst/>
@@ -7084,7 +7811,7 @@
       </p:pic>
       <p:sp>
         <p:nvSpPr>
-          <p:cNvPr id="18" name="Text 15"/>
+          <p:cNvPr id="9" name="Text 6"/>
           <p:cNvSpPr/>
           <p:nvPr/>
         </p:nvSpPr>
@@ -7120,7 +7847,7 @@
       </p:sp>
       <p:sp>
         <p:nvSpPr>
-          <p:cNvPr id="19" name="Text 16"/>
+          <p:cNvPr id="10" name="Text 7"/>
           <p:cNvSpPr/>
           <p:nvPr/>
         </p:nvSpPr>
@@ -7148,7 +7875,7 @@
                   <a:srgbClr val="6B7890"/>
                 </a:solidFill>
               </a:rPr>
-              <a:t>9 / 10</a:t>
+              <a:t>9 / 11</a:t>
             </a:r>
             <a:endParaRPr lang="en-US" sz="900" dirty="0"/>
           </a:p>

</xml_diff>